<commit_message>
update ref and other staged commits
</commit_message>
<xml_diff>
--- a/materials/Afternoon Session/Structure Priors and Clustering/Structure_priors_Theory.pptx
+++ b/materials/Afternoon Session/Structure Priors and Clustering/Structure_priors_Theory.pptx
@@ -156,7 +156,7 @@
   <pc:docChgLst>
     <pc:chgData name="Nikola Sekulovski" userId="2345901e-73d2-462d-8b82-8af2d9a2a087" providerId="ADAL" clId="{64B89F19-5709-53FC-B79D-01CD083CA518}"/>
     <pc:docChg chg="custSel addSld delSld modSld">
-      <pc:chgData name="Nikola Sekulovski" userId="2345901e-73d2-462d-8b82-8af2d9a2a087" providerId="ADAL" clId="{64B89F19-5709-53FC-B79D-01CD083CA518}" dt="2026-06-26T08:29:14.745" v="173" actId="20577"/>
+      <pc:chgData name="Nikola Sekulovski" userId="2345901e-73d2-462d-8b82-8af2d9a2a087" providerId="ADAL" clId="{64B89F19-5709-53FC-B79D-01CD083CA518}" dt="2026-06-26T11:56:06.443" v="175" actId="20577"/>
       <pc:docMkLst>
         <pc:docMk/>
       </pc:docMkLst>
@@ -255,12 +255,20 @@
           </ac:spMkLst>
         </pc:spChg>
       </pc:sldChg>
-      <pc:sldChg chg="add">
-        <pc:chgData name="Nikola Sekulovski" userId="2345901e-73d2-462d-8b82-8af2d9a2a087" providerId="ADAL" clId="{64B89F19-5709-53FC-B79D-01CD083CA518}" dt="2026-06-22T11:52:22.786" v="31"/>
+      <pc:sldChg chg="modSp add mod">
+        <pc:chgData name="Nikola Sekulovski" userId="2345901e-73d2-462d-8b82-8af2d9a2a087" providerId="ADAL" clId="{64B89F19-5709-53FC-B79D-01CD083CA518}" dt="2026-06-26T11:56:06.443" v="175" actId="20577"/>
         <pc:sldMkLst>
           <pc:docMk/>
           <pc:sldMk cId="0" sldId="855"/>
         </pc:sldMkLst>
+        <pc:spChg chg="mod">
+          <ac:chgData name="Nikola Sekulovski" userId="2345901e-73d2-462d-8b82-8af2d9a2a087" providerId="ADAL" clId="{64B89F19-5709-53FC-B79D-01CD083CA518}" dt="2026-06-26T11:56:06.443" v="175" actId="20577"/>
+          <ac:spMkLst>
+            <pc:docMk/>
+            <pc:sldMk cId="0" sldId="855"/>
+            <ac:spMk id="2" creationId="{FE865504-4B32-6E88-493A-E48E3FA52C1A}"/>
+          </ac:spMkLst>
+        </pc:spChg>
       </pc:sldChg>
       <pc:sldChg chg="modSp add mod">
         <pc:chgData name="Nikola Sekulovski" userId="2345901e-73d2-462d-8b82-8af2d9a2a087" providerId="ADAL" clId="{64B89F19-5709-53FC-B79D-01CD083CA518}" dt="2026-06-26T08:26:32.403" v="85" actId="20577"/>
@@ -6344,8 +6352,25 @@
                   </a:schemeClr>
                 </a:solidFill>
               </a:rPr>
-              <a:t>/29p3m_v3</a:t>
-            </a:r>
+              <a:t>/29p3m</a:t>
+            </a:r>
+            <a:r>
+              <a:rPr lang="en-US" sz="1100">
+                <a:solidFill>
+                  <a:schemeClr val="bg1">
+                    <a:lumMod val="65000"/>
+                  </a:schemeClr>
+                </a:solidFill>
+              </a:rPr>
+              <a:t>_v4</a:t>
+            </a:r>
+            <a:endParaRPr lang="en-US" sz="1100" dirty="0">
+              <a:solidFill>
+                <a:schemeClr val="bg1">
+                  <a:lumMod val="65000"/>
+                </a:schemeClr>
+              </a:solidFill>
+            </a:endParaRPr>
           </a:p>
           <a:p>
             <a:endParaRPr lang="en-US" dirty="0"/>

</xml_diff>